<commit_message>
260923 - previous updates
</commit_message>
<xml_diff>
--- a/MK_Command_meeting_slides_260910.pptx
+++ b/MK_Command_meeting_slides_260910.pptx
@@ -3376,7 +3376,7 @@
                 </a:solidFill>
                 <a:latin typeface="Calibri"/>
               </a:rPr>
-              <a:t>6 operating companies  ·  724 active staff  ·  951 general workers  ·  927 job spec versions  ·  1,065 merit/demerit records</a:t>
+              <a:t>6 operating companies  ·  710 active staff  ·  346 general workers  ·  927 job spec versions  ·  1,065 merit/demerit records</a:t>
             </a:r>
           </a:p>
         </p:txBody>
@@ -8962,7 +8962,7 @@
                 </a:solidFill>
                 <a:latin typeface="Calibri"/>
               </a:rPr>
-              <a:t>76 of 84 memos (90%) came from one person, logged under two spellings of their name. The other three senders have used it once or twice each.</a:t>
+              <a:t>76 of 84 memos (90%) came from one person, logged under two spellings of their name. The Deputy CEO accounts for six; two other people have sent one each.</a:t>
             </a:r>
           </a:p>
         </p:txBody>
@@ -11404,7 +11404,7 @@
                 </a:solidFill>
                 <a:latin typeface="Cambria"/>
               </a:rPr>
-              <a:t>724</a:t>
+              <a:t>710</a:t>
             </a:r>
           </a:p>
         </p:txBody>
@@ -12401,7 +12401,7 @@
                 </a:solidFill>
                 <a:latin typeface="Calibri"/>
               </a:rPr>
-              <a:t>All figures re-queried from the live system on 10 Sep 2026. Staff counts on the manpower basis (active, not deleted); job spec and general worker figures on the same basis as the application's own approval report.</a:t>
+              <a:t>All figures re-queried from the live system on 10 Sep 2026. Staff and general worker counts on the same basis as the MK Command staff overview page; job spec figures on the same basis as the application's own approval report.</a:t>
             </a:r>
           </a:p>
         </p:txBody>
@@ -12867,7 +12867,7 @@
                 </a:solidFill>
                 <a:latin typeface="Calibri"/>
               </a:rPr>
-              <a:t>724 active staff group-wide, and 951 general workers across Globinaco and Arus Sawit.</a:t>
+              <a:t>710 active staff group-wide, plus 346 general workers at Globinaco.</a:t>
             </a:r>
           </a:p>
         </p:txBody>
@@ -13036,7 +13036,7 @@
                 </a:solidFill>
                 <a:latin typeface="Cambria"/>
               </a:rPr>
-              <a:t>724</a:t>
+              <a:t>710</a:t>
             </a:r>
           </a:p>
         </p:txBody>
@@ -13110,7 +13110,7 @@
                 </a:solidFill>
                 <a:latin typeface="Calibri"/>
               </a:rPr>
-              <a:t>Across all 6 companies. Up 3 since the August pack.</a:t>
+              <a:t>Across all 6 companies, counted as MK Command itself counts them.</a:t>
             </a:r>
           </a:p>
         </p:txBody>
@@ -13235,7 +13235,7 @@
                 </a:solidFill>
                 <a:latin typeface="Cambria"/>
               </a:rPr>
-              <a:t>951</a:t>
+              <a:t>346</a:t>
             </a:r>
           </a:p>
         </p:txBody>
@@ -13309,7 +13309,7 @@
                 </a:solidFill>
                 <a:latin typeface="Calibri"/>
               </a:rPr>
-              <a:t>359 at Globinaco, 592 at Arus Sawit — more than the staff headcount itself.</a:t>
+              <a:t>All at Globinaco, where they nearly match its own staff headcount of 352.</a:t>
             </a:r>
           </a:p>
         </p:txBody>
@@ -13434,7 +13434,7 @@
                 </a:solidFill>
                 <a:latin typeface="Cambria"/>
               </a:rPr>
-              <a:t>1,675</a:t>
+              <a:t>1,056</a:t>
             </a:r>
           </a:p>
         </p:txBody>
@@ -13815,7 +13815,7 @@
                 </a:solidFill>
                 <a:latin typeface="Calibri"/>
               </a:rPr>
-              <a:t>366</a:t>
+              <a:t>352</a:t>
             </a:r>
           </a:p>
         </p:txBody>
@@ -13850,7 +13850,7 @@
                 </a:solidFill>
                 <a:latin typeface="Calibri"/>
               </a:rPr>
-              <a:t>359</a:t>
+              <a:t>346</a:t>
             </a:r>
           </a:p>
         </p:txBody>
@@ -14236,7 +14236,7 @@
                 </a:solidFill>
                 <a:latin typeface="Calibri"/>
               </a:rPr>
-              <a:t>592</a:t>
+              <a:t>—</a:t>
             </a:r>
           </a:p>
         </p:txBody>
@@ -14973,7 +14973,7 @@
                 </a:solidFill>
                 <a:latin typeface="Calibri"/>
               </a:rPr>
-              <a:t>724</a:t>
+              <a:t>710</a:t>
             </a:r>
           </a:p>
         </p:txBody>
@@ -15008,7 +15008,7 @@
                 </a:solidFill>
                 <a:latin typeface="Calibri"/>
               </a:rPr>
-              <a:t>951</a:t>
+              <a:t>346</a:t>
             </a:r>
           </a:p>
         </p:txBody>
@@ -15074,7 +15074,7 @@
             <a:avLst/>
           </a:prstGeom>
           <a:solidFill>
-            <a:srgbClr val="C62828"/>
+            <a:srgbClr val="F9A825"/>
           </a:solidFill>
           <a:ln>
             <a:noFill/>
@@ -15129,11 +15129,11 @@
             <a:r>
               <a:rPr sz="1150" b="1">
                 <a:solidFill>
-                  <a:srgbClr val="C62828"/>
-                </a:solidFill>
-                <a:latin typeface="Calibri"/>
-              </a:rPr>
-              <a:t>Arus Sawit's general workers were missing from the last pack</a:t>
+                  <a:srgbClr val="F9A825"/>
+                </a:solidFill>
+                <a:latin typeface="Calibri"/>
+              </a:rPr>
+              <a:t>Half of Globinaco's workforce is general workers</a:t>
             </a:r>
           </a:p>
         </p:txBody>
@@ -15172,7 +15172,7 @@
                 </a:solidFill>
                 <a:latin typeface="Calibri"/>
               </a:rPr>
-              <a:t>592 live general workers have been on file at Arus Sawit throughout. The August deck showed general workers at Globinaco only: nothing was added since, the earlier count was scoped too narrowly.</a:t>
+              <a:t>346 general workers against 352 staff. Globinaco is the only company in the group with a general worker population under review, and it is nearly as large as its own staff headcount.</a:t>
             </a:r>
           </a:p>
         </p:txBody>
@@ -15238,7 +15238,7 @@
             <a:avLst/>
           </a:prstGeom>
           <a:solidFill>
-            <a:srgbClr val="F9A825"/>
+            <a:srgbClr val="1E2761"/>
           </a:solidFill>
           <a:ln>
             <a:noFill/>
@@ -15293,11 +15293,11 @@
             <a:r>
               <a:rPr sz="1150" b="1">
                 <a:solidFill>
-                  <a:srgbClr val="F9A825"/>
-                </a:solidFill>
-                <a:latin typeface="Calibri"/>
-              </a:rPr>
-              <a:t>Job specs are still a staff-only instrument</a:t>
+                  <a:srgbClr val="1E2761"/>
+                </a:solidFill>
+                <a:latin typeface="Calibri"/>
+              </a:rPr>
+              <a:t>A general worker's record is a job spec and nothing else</a:t>
             </a:r>
           </a:p>
         </p:txBody>
@@ -15336,7 +15336,7 @@
                 </a:solidFill>
                 <a:latin typeface="Calibri"/>
               </a:rPr>
-              <a:t>General workers now outnumber staff 951 to 724, but only Globinaco's have any job spec on file. Arus Sawit's 592 have none.</a:t>
+              <a:t>Those 346 hold 337 job spec versions between them, but the tool holds no memo, merit/demerit or application record against any of them.</a:t>
             </a:r>
           </a:p>
         </p:txBody>
@@ -15371,7 +15371,7 @@
                 </a:solidFill>
                 <a:latin typeface="Calibri"/>
               </a:rPr>
-              <a:t>Active staff on the manpower basis (active, not deleted). General workers on the live scorecard population. Remarks: staff list not updated at every company; job spec only provided for staff.</a:t>
+              <a:t>Counted on the same basis as the MK Command staff overview page: active, not deleted, not excluded from MK Command; general workers counted as people, so a worker assigned to two supervisors is counted once. The manpower report uses a wider staff basis and shows 724. General workers here are Globinaco's only; Arus Sawit's separate population is outside this review. Remarks: staff list not updated at every company; job spec only provided for staff.</a:t>
             </a:r>
           </a:p>
         </p:txBody>
@@ -15582,7 +15582,7 @@
                 </a:solidFill>
                 <a:latin typeface="Calibri"/>
               </a:rPr>
-              <a:t>Active staff currently on file for each company, per the manpower report.</a:t>
+              <a:t>Active staff currently visible in MK Command for each company.</a:t>
             </a:r>
           </a:p>
         </p:txBody>
@@ -15786,7 +15786,7 @@
                 </a:solidFill>
                 <a:latin typeface="Cambria"/>
               </a:rPr>
-              <a:t>366</a:t>
+              <a:t>352</a:t>
             </a:r>
           </a:p>
         </p:txBody>
@@ -15891,7 +15891,7 @@
                 </a:solidFill>
                 <a:latin typeface="Calibri"/>
               </a:rPr>
-              <a:t>359</a:t>
+              <a:t>346</a:t>
             </a:r>
           </a:p>
         </p:txBody>
@@ -15961,7 +15961,7 @@
                 </a:solidFill>
                 <a:latin typeface="Calibri"/>
               </a:rPr>
-              <a:t>51%</a:t>
+              <a:t>50%</a:t>
             </a:r>
           </a:p>
         </p:txBody>
@@ -16044,7 +16044,7 @@
                 </a:solidFill>
                 <a:latin typeface="Calibri"/>
               </a:rPr>
-              <a:t>366 of 724 group-wide active staff. Largest employer in the group, and half of it.</a:t>
+              <a:t>352 of 710 group-wide active staff. Largest employer in the group, and half of it. Its 346 general workers are counted separately.</a:t>
             </a:r>
           </a:p>
         </p:txBody>
@@ -16392,7 +16392,7 @@
                 </a:solidFill>
                 <a:latin typeface="Calibri"/>
               </a:rPr>
-              <a:t>150 of 724 group-wide active staff.</a:t>
+              <a:t>150 of 710 group-wide active staff.</a:t>
             </a:r>
           </a:p>
         </p:txBody>
@@ -16622,7 +16622,7 @@
                 </a:solidFill>
                 <a:latin typeface="Calibri"/>
               </a:rPr>
-              <a:t>General workers</a:t>
+              <a:t>Share of group</a:t>
             </a:r>
           </a:p>
         </p:txBody>
@@ -16653,76 +16653,6 @@
             <a:r>
               <a:rPr sz="1050" b="1">
                 <a:solidFill>
-                  <a:srgbClr val="F9A825"/>
-                </a:solidFill>
-                <a:latin typeface="Calibri"/>
-              </a:rPr>
-              <a:t>592</a:t>
-            </a:r>
-          </a:p>
-        </p:txBody>
-      </p:sp>
-      <p:sp>
-        <p:nvSpPr>
-          <p:cNvPr id="35" name="TextBox 34"/>
-          <p:cNvSpPr txBox="1"/>
-          <p:nvPr/>
-        </p:nvSpPr>
-        <p:spPr>
-          <a:xfrm>
-            <a:off x="10296142" y="2318004"/>
-            <a:ext cx="1051560" cy="201168"/>
-          </a:xfrm>
-          <a:prstGeom prst="rect">
-            <a:avLst/>
-          </a:prstGeom>
-          <a:noFill/>
-        </p:spPr>
-        <p:txBody>
-          <a:bodyPr wrap="square" lIns="0" rIns="0" tIns="0" bIns="0" anchor="t">
-            <a:spAutoFit/>
-          </a:bodyPr>
-          <a:lstStyle/>
-          <a:p>
-            <a:pPr algn="l"/>
-            <a:r>
-              <a:rPr sz="850" b="0">
-                <a:solidFill>
-                  <a:srgbClr val="5A6478"/>
-                </a:solidFill>
-                <a:latin typeface="Calibri"/>
-              </a:rPr>
-              <a:t>Share of group</a:t>
-            </a:r>
-          </a:p>
-        </p:txBody>
-      </p:sp>
-      <p:sp>
-        <p:nvSpPr>
-          <p:cNvPr id="36" name="TextBox 35"/>
-          <p:cNvSpPr txBox="1"/>
-          <p:nvPr/>
-        </p:nvSpPr>
-        <p:spPr>
-          <a:xfrm>
-            <a:off x="11320270" y="2299716"/>
-            <a:ext cx="512064" cy="219456"/>
-          </a:xfrm>
-          <a:prstGeom prst="rect">
-            <a:avLst/>
-          </a:prstGeom>
-          <a:noFill/>
-        </p:spPr>
-        <p:txBody>
-          <a:bodyPr wrap="square" lIns="0" rIns="0" tIns="0" bIns="0" anchor="t">
-            <a:spAutoFit/>
-          </a:bodyPr>
-          <a:lstStyle/>
-          <a:p>
-            <a:pPr algn="r"/>
-            <a:r>
-              <a:rPr sz="1050" b="1">
-                <a:solidFill>
                   <a:srgbClr val="1E2761"/>
                 </a:solidFill>
                 <a:latin typeface="Calibri"/>
@@ -16734,7 +16664,7 @@
       </p:sp>
       <p:sp>
         <p:nvSpPr>
-          <p:cNvPr id="37" name="Rectangle 36"/>
+          <p:cNvPr id="35" name="Rectangle 34"/>
           <p:cNvSpPr/>
           <p:nvPr/>
         </p:nvSpPr>
@@ -16778,7 +16708,7 @@
       </p:sp>
       <p:sp>
         <p:nvSpPr>
-          <p:cNvPr id="38" name="TextBox 37"/>
+          <p:cNvPr id="36" name="TextBox 35"/>
           <p:cNvSpPr txBox="1"/>
           <p:nvPr/>
         </p:nvSpPr>
@@ -16810,14 +16740,14 @@
                 </a:solidFill>
                 <a:latin typeface="Calibri"/>
               </a:rPr>
-              <a:t>92 of 724 group-wide active staff. Its 592 general workers are six times its own staff headcount.</a:t>
-            </a:r>
-          </a:p>
-        </p:txBody>
-      </p:sp>
-      <p:sp>
-        <p:nvSpPr>
-          <p:cNvPr id="39" name="Rectangle 38"/>
+              <a:t>92 of 710 group-wide active staff.</a:t>
+            </a:r>
+          </a:p>
+        </p:txBody>
+      </p:sp>
+      <p:sp>
+        <p:nvSpPr>
+          <p:cNvPr id="37" name="Rectangle 36"/>
           <p:cNvSpPr/>
           <p:nvPr/>
         </p:nvSpPr>
@@ -16863,7 +16793,7 @@
       </p:sp>
       <p:sp>
         <p:nvSpPr>
-          <p:cNvPr id="40" name="Rectangle 39"/>
+          <p:cNvPr id="38" name="Rectangle 37"/>
           <p:cNvSpPr/>
           <p:nvPr/>
         </p:nvSpPr>
@@ -16907,7 +16837,7 @@
       </p:sp>
       <p:sp>
         <p:nvSpPr>
-          <p:cNvPr id="41" name="TextBox 40"/>
+          <p:cNvPr id="39" name="TextBox 38"/>
           <p:cNvSpPr txBox="1"/>
           <p:nvPr/>
         </p:nvSpPr>
@@ -16942,7 +16872,7 @@
       </p:sp>
       <p:sp>
         <p:nvSpPr>
-          <p:cNvPr id="42" name="TextBox 41"/>
+          <p:cNvPr id="40" name="TextBox 39"/>
           <p:cNvSpPr txBox="1"/>
           <p:nvPr/>
         </p:nvSpPr>
@@ -16977,7 +16907,7 @@
       </p:sp>
       <p:sp>
         <p:nvSpPr>
-          <p:cNvPr id="43" name="TextBox 42"/>
+          <p:cNvPr id="41" name="TextBox 40"/>
           <p:cNvSpPr txBox="1"/>
           <p:nvPr/>
         </p:nvSpPr>
@@ -17012,7 +16942,7 @@
       </p:sp>
       <p:sp>
         <p:nvSpPr>
-          <p:cNvPr id="44" name="TextBox 43"/>
+          <p:cNvPr id="42" name="TextBox 41"/>
           <p:cNvSpPr txBox="1"/>
           <p:nvPr/>
         </p:nvSpPr>
@@ -17047,7 +16977,7 @@
       </p:sp>
       <p:sp>
         <p:nvSpPr>
-          <p:cNvPr id="45" name="TextBox 44"/>
+          <p:cNvPr id="43" name="TextBox 42"/>
           <p:cNvSpPr txBox="1"/>
           <p:nvPr/>
         </p:nvSpPr>
@@ -17082,7 +17012,7 @@
       </p:sp>
       <p:sp>
         <p:nvSpPr>
-          <p:cNvPr id="46" name="Rectangle 45"/>
+          <p:cNvPr id="44" name="Rectangle 43"/>
           <p:cNvSpPr/>
           <p:nvPr/>
         </p:nvSpPr>
@@ -17126,7 +17056,7 @@
       </p:sp>
       <p:sp>
         <p:nvSpPr>
-          <p:cNvPr id="47" name="TextBox 46"/>
+          <p:cNvPr id="45" name="TextBox 44"/>
           <p:cNvSpPr txBox="1"/>
           <p:nvPr/>
         </p:nvSpPr>
@@ -17158,14 +17088,14 @@
                 </a:solidFill>
                 <a:latin typeface="Calibri"/>
               </a:rPr>
-              <a:t>57 of 724 group-wide active staff.</a:t>
-            </a:r>
-          </a:p>
-        </p:txBody>
-      </p:sp>
-      <p:sp>
-        <p:nvSpPr>
-          <p:cNvPr id="48" name="Rectangle 47"/>
+              <a:t>57 of 710 group-wide active staff.</a:t>
+            </a:r>
+          </a:p>
+        </p:txBody>
+      </p:sp>
+      <p:sp>
+        <p:nvSpPr>
+          <p:cNvPr id="46" name="Rectangle 45"/>
           <p:cNvSpPr/>
           <p:nvPr/>
         </p:nvSpPr>
@@ -17211,7 +17141,7 @@
       </p:sp>
       <p:sp>
         <p:nvSpPr>
-          <p:cNvPr id="49" name="Rectangle 48"/>
+          <p:cNvPr id="47" name="Rectangle 46"/>
           <p:cNvSpPr/>
           <p:nvPr/>
         </p:nvSpPr>
@@ -17255,7 +17185,7 @@
       </p:sp>
       <p:sp>
         <p:nvSpPr>
-          <p:cNvPr id="50" name="TextBox 49"/>
+          <p:cNvPr id="48" name="TextBox 47"/>
           <p:cNvSpPr txBox="1"/>
           <p:nvPr/>
         </p:nvSpPr>
@@ -17290,7 +17220,7 @@
       </p:sp>
       <p:sp>
         <p:nvSpPr>
-          <p:cNvPr id="51" name="TextBox 50"/>
+          <p:cNvPr id="49" name="TextBox 48"/>
           <p:cNvSpPr txBox="1"/>
           <p:nvPr/>
         </p:nvSpPr>
@@ -17325,7 +17255,7 @@
       </p:sp>
       <p:sp>
         <p:nvSpPr>
-          <p:cNvPr id="52" name="TextBox 51"/>
+          <p:cNvPr id="50" name="TextBox 49"/>
           <p:cNvSpPr txBox="1"/>
           <p:nvPr/>
         </p:nvSpPr>
@@ -17360,7 +17290,7 @@
       </p:sp>
       <p:sp>
         <p:nvSpPr>
-          <p:cNvPr id="53" name="TextBox 52"/>
+          <p:cNvPr id="51" name="TextBox 50"/>
           <p:cNvSpPr txBox="1"/>
           <p:nvPr/>
         </p:nvSpPr>
@@ -17395,7 +17325,7 @@
       </p:sp>
       <p:sp>
         <p:nvSpPr>
-          <p:cNvPr id="54" name="TextBox 53"/>
+          <p:cNvPr id="52" name="TextBox 51"/>
           <p:cNvSpPr txBox="1"/>
           <p:nvPr/>
         </p:nvSpPr>
@@ -17430,7 +17360,7 @@
       </p:sp>
       <p:sp>
         <p:nvSpPr>
-          <p:cNvPr id="55" name="Rectangle 54"/>
+          <p:cNvPr id="53" name="Rectangle 52"/>
           <p:cNvSpPr/>
           <p:nvPr/>
         </p:nvSpPr>
@@ -17474,7 +17404,7 @@
       </p:sp>
       <p:sp>
         <p:nvSpPr>
-          <p:cNvPr id="56" name="TextBox 55"/>
+          <p:cNvPr id="54" name="TextBox 53"/>
           <p:cNvSpPr txBox="1"/>
           <p:nvPr/>
         </p:nvSpPr>
@@ -17506,14 +17436,14 @@
                 </a:solidFill>
                 <a:latin typeface="Calibri"/>
               </a:rPr>
-              <a:t>51 of 724 group-wide active staff.</a:t>
-            </a:r>
-          </a:p>
-        </p:txBody>
-      </p:sp>
-      <p:sp>
-        <p:nvSpPr>
-          <p:cNvPr id="57" name="Rectangle 56"/>
+              <a:t>51 of 710 group-wide active staff.</a:t>
+            </a:r>
+          </a:p>
+        </p:txBody>
+      </p:sp>
+      <p:sp>
+        <p:nvSpPr>
+          <p:cNvPr id="55" name="Rectangle 54"/>
           <p:cNvSpPr/>
           <p:nvPr/>
         </p:nvSpPr>
@@ -17559,7 +17489,7 @@
       </p:sp>
       <p:sp>
         <p:nvSpPr>
-          <p:cNvPr id="58" name="Rectangle 57"/>
+          <p:cNvPr id="56" name="Rectangle 55"/>
           <p:cNvSpPr/>
           <p:nvPr/>
         </p:nvSpPr>
@@ -17603,7 +17533,7 @@
       </p:sp>
       <p:sp>
         <p:nvSpPr>
-          <p:cNvPr id="59" name="TextBox 58"/>
+          <p:cNvPr id="57" name="TextBox 56"/>
           <p:cNvSpPr txBox="1"/>
           <p:nvPr/>
         </p:nvSpPr>
@@ -17638,7 +17568,7 @@
       </p:sp>
       <p:sp>
         <p:nvSpPr>
-          <p:cNvPr id="60" name="TextBox 59"/>
+          <p:cNvPr id="58" name="TextBox 57"/>
           <p:cNvSpPr txBox="1"/>
           <p:nvPr/>
         </p:nvSpPr>
@@ -17673,7 +17603,7 @@
       </p:sp>
       <p:sp>
         <p:nvSpPr>
-          <p:cNvPr id="61" name="TextBox 60"/>
+          <p:cNvPr id="59" name="TextBox 58"/>
           <p:cNvSpPr txBox="1"/>
           <p:nvPr/>
         </p:nvSpPr>
@@ -17708,7 +17638,7 @@
       </p:sp>
       <p:sp>
         <p:nvSpPr>
-          <p:cNvPr id="62" name="TextBox 61"/>
+          <p:cNvPr id="60" name="TextBox 59"/>
           <p:cNvSpPr txBox="1"/>
           <p:nvPr/>
         </p:nvSpPr>
@@ -17743,7 +17673,7 @@
       </p:sp>
       <p:sp>
         <p:nvSpPr>
-          <p:cNvPr id="63" name="TextBox 62"/>
+          <p:cNvPr id="61" name="TextBox 60"/>
           <p:cNvSpPr txBox="1"/>
           <p:nvPr/>
         </p:nvSpPr>
@@ -17778,7 +17708,7 @@
       </p:sp>
       <p:sp>
         <p:nvSpPr>
-          <p:cNvPr id="64" name="Rectangle 63"/>
+          <p:cNvPr id="62" name="Rectangle 61"/>
           <p:cNvSpPr/>
           <p:nvPr/>
         </p:nvSpPr>
@@ -17822,7 +17752,7 @@
       </p:sp>
       <p:sp>
         <p:nvSpPr>
-          <p:cNvPr id="65" name="TextBox 64"/>
+          <p:cNvPr id="63" name="TextBox 62"/>
           <p:cNvSpPr txBox="1"/>
           <p:nvPr/>
         </p:nvSpPr>
@@ -17854,14 +17784,14 @@
                 </a:solidFill>
                 <a:latin typeface="Calibri"/>
               </a:rPr>
-              <a:t>8 of 724 group-wide active staff.</a:t>
-            </a:r>
-          </a:p>
-        </p:txBody>
-      </p:sp>
-      <p:sp>
-        <p:nvSpPr>
-          <p:cNvPr id="66" name="TextBox 65"/>
+              <a:t>8 of 710 group-wide active staff.</a:t>
+            </a:r>
+          </a:p>
+        </p:txBody>
+      </p:sp>
+      <p:sp>
+        <p:nvSpPr>
+          <p:cNvPr id="64" name="TextBox 63"/>
           <p:cNvSpPr txBox="1"/>
           <p:nvPr/>
         </p:nvSpPr>
@@ -17889,7 +17819,7 @@
                 </a:solidFill>
                 <a:latin typeface="Calibri"/>
               </a:rPr>
-              <a:t>Manpower basis (active, not deleted). The MK Command tool's own basis excludes 14 more people at Globinaco (352), which is a mobile-app visibility setting rather than an HR headcount concept.</a:t>
+              <a:t>Same basis as the MK Command staff overview page. The manpower report counts 14 more people at Globinaco (366, and 724 group-wide) because it does not apply the MK Command exclusion, which is a tool-visibility setting rather than an HR headcount concept.</a:t>
             </a:r>
           </a:p>
         </p:txBody>
@@ -18887,7 +18817,7 @@
                 </a:solidFill>
                 <a:latin typeface="Calibri"/>
               </a:rPr>
-              <a:t>82% still pending — the group's approval bottleneck sits here, and 336 of those are general worker specs.</a:t>
+              <a:t>82% still pending, 336 of them general worker specs. Approvals moved (99 to 114) but the bottleneck still sits here.</a:t>
             </a:r>
           </a:p>
         </p:txBody>

</xml_diff>